<commit_message>
Enhance PPT presentation with a dark cyan theme
</commit_message>
<xml_diff>
--- a/docs/TrueJob_Presentation.pptx
+++ b/docs/TrueJob_Presentation.pptx
@@ -3090,6 +3090,14 @@
 <file path=ppt/slides/slide1.xml><?xml version="1.0" encoding="utf-8"?>
 <p:sld xmlns:a="http://schemas.openxmlformats.org/drawingml/2006/main" xmlns:p="http://schemas.openxmlformats.org/presentationml/2006/main" xmlns:r="http://schemas.openxmlformats.org/officeDocument/2006/relationships">
   <p:cSld>
+    <p:bg>
+      <p:bgPr>
+        <a:solidFill>
+          <a:srgbClr val="18212D"/>
+        </a:solidFill>
+        <a:effectLst/>
+      </p:bgPr>
+    </p:bg>
     <p:spTree>
       <p:nvGrpSpPr>
         <p:cNvPr id="1" name=""/>
@@ -3113,6 +3121,12 @@
           <a:lstStyle/>
           <a:p>
             <a:r>
+              <a:rPr sz="4000" b="1">
+                <a:solidFill>
+                  <a:srgbClr val="40E0D0"/>
+                </a:solidFill>
+                <a:latin typeface="Segoe UI"/>
+              </a:rPr>
               <a:t>TrueJob: Fake Job Posting Detection</a:t>
             </a:r>
           </a:p>
@@ -3134,16 +3148,35 @@
           <a:lstStyle/>
           <a:p>
             <a:r>
+              <a:rPr sz="2200">
+                <a:solidFill>
+                  <a:srgbClr val="DCDCDC"/>
+                </a:solidFill>
+                <a:latin typeface="Segoe UI"/>
+              </a:rPr>
               <a:t>A Machine Learning approach using NLP</a:t>
             </a:r>
           </a:p>
-          <a:p>
-            <a:r>
+          <a:p/>
+          <a:p>
+            <a:r>
+              <a:rPr sz="2200">
+                <a:solidFill>
+                  <a:srgbClr val="DCDCDC"/>
+                </a:solidFill>
+                <a:latin typeface="Segoe UI"/>
+              </a:rPr>
               <a:t>Presented by: Arman Rizvi</a:t>
             </a:r>
           </a:p>
           <a:p>
             <a:r>
+              <a:rPr sz="2200">
+                <a:solidFill>
+                  <a:srgbClr val="DCDCDC"/>
+                </a:solidFill>
+                <a:latin typeface="Segoe UI"/>
+              </a:rPr>
               <a:t>3rd Year B.Tech, Data Science &amp; AI</a:t>
             </a:r>
           </a:p>
@@ -3160,6 +3193,14 @@
 <file path=ppt/slides/slide10.xml><?xml version="1.0" encoding="utf-8"?>
 <p:sld xmlns:a="http://schemas.openxmlformats.org/drawingml/2006/main" xmlns:p="http://schemas.openxmlformats.org/presentationml/2006/main" xmlns:r="http://schemas.openxmlformats.org/officeDocument/2006/relationships">
   <p:cSld>
+    <p:bg>
+      <p:bgPr>
+        <a:solidFill>
+          <a:srgbClr val="18212D"/>
+        </a:solidFill>
+        <a:effectLst/>
+      </p:bgPr>
+    </p:bg>
     <p:spTree>
       <p:nvGrpSpPr>
         <p:cNvPr id="1" name=""/>
@@ -3183,6 +3224,12 @@
           <a:lstStyle/>
           <a:p>
             <a:r>
+              <a:rPr sz="4000" b="1">
+                <a:solidFill>
+                  <a:srgbClr val="40E0D0"/>
+                </a:solidFill>
+                <a:latin typeface="Segoe UI"/>
+              </a:rPr>
               <a:t>Conclusion &amp; Future Scope</a:t>
             </a:r>
           </a:p>
@@ -3202,44 +3249,88 @@
         <p:txBody>
           <a:bodyPr/>
           <a:lstStyle/>
-          <a:p>
-            <a:r>
+          <a:p/>
+          <a:p>
+            <a:pPr/>
+            <a:r>
+              <a:rPr sz="2200">
+                <a:solidFill>
+                  <a:srgbClr val="F0F0F0"/>
+                </a:solidFill>
+                <a:latin typeface="Segoe UI"/>
+              </a:rPr>
               <a:t>Conclusion:</a:t>
             </a:r>
           </a:p>
           <a:p>
             <a:pPr/>
             <a:r>
+              <a:rPr sz="2200">
+                <a:solidFill>
+                  <a:srgbClr val="F0F0F0"/>
+                </a:solidFill>
+                <a:latin typeface="Segoe UI"/>
+              </a:rPr>
               <a:t>- Successfully built an end-to-end ML pipeline.</a:t>
             </a:r>
           </a:p>
           <a:p>
             <a:pPr/>
             <a:r>
+              <a:rPr sz="2200">
+                <a:solidFill>
+                  <a:srgbClr val="F0F0F0"/>
+                </a:solidFill>
+                <a:latin typeface="Segoe UI"/>
+              </a:rPr>
               <a:t>- Proved that Linear SVC outperforms others on sparse text data.</a:t>
             </a:r>
           </a:p>
           <a:p>
             <a:pPr/>
             <a:r>
-              <a:t>- Demonstrated the danger of relying purely on Accuracy.</a:t>
+              <a:rPr sz="2200">
+                <a:solidFill>
+                  <a:srgbClr val="F0F0F0"/>
+                </a:solidFill>
+                <a:latin typeface="Segoe UI"/>
+              </a:rPr>
+              <a:t>- Demonstrated the danger of relying purely on Accuracy in imbalanced data.</a:t>
             </a:r>
           </a:p>
           <a:p>
             <a:pPr/>
             <a:r>
+              <a:rPr sz="2200">
+                <a:solidFill>
+                  <a:srgbClr val="F0F0F0"/>
+                </a:solidFill>
+                <a:latin typeface="Segoe UI"/>
+              </a:rPr>
               <a:t>Future Scope:</a:t>
             </a:r>
           </a:p>
           <a:p>
             <a:pPr/>
             <a:r>
+              <a:rPr sz="2200">
+                <a:solidFill>
+                  <a:srgbClr val="F0F0F0"/>
+                </a:solidFill>
+                <a:latin typeface="Segoe UI"/>
+              </a:rPr>
               <a:t>- Upgrade from TF-IDF to Transformer models (BERT).</a:t>
             </a:r>
           </a:p>
           <a:p>
             <a:pPr/>
             <a:r>
+              <a:rPr sz="2200">
+                <a:solidFill>
+                  <a:srgbClr val="F0F0F0"/>
+                </a:solidFill>
+                <a:latin typeface="Segoe UI"/>
+              </a:rPr>
               <a:t>- Deploy as a Google Chrome browser extension for live web scanning.</a:t>
             </a:r>
           </a:p>
@@ -3256,6 +3347,14 @@
 <file path=ppt/slides/slide2.xml><?xml version="1.0" encoding="utf-8"?>
 <p:sld xmlns:a="http://schemas.openxmlformats.org/drawingml/2006/main" xmlns:p="http://schemas.openxmlformats.org/presentationml/2006/main" xmlns:r="http://schemas.openxmlformats.org/officeDocument/2006/relationships">
   <p:cSld>
+    <p:bg>
+      <p:bgPr>
+        <a:solidFill>
+          <a:srgbClr val="18212D"/>
+        </a:solidFill>
+        <a:effectLst/>
+      </p:bgPr>
+    </p:bg>
     <p:spTree>
       <p:nvGrpSpPr>
         <p:cNvPr id="1" name=""/>
@@ -3279,6 +3378,12 @@
           <a:lstStyle/>
           <a:p>
             <a:r>
+              <a:rPr sz="4000" b="1">
+                <a:solidFill>
+                  <a:srgbClr val="40E0D0"/>
+                </a:solidFill>
+                <a:latin typeface="Segoe UI"/>
+              </a:rPr>
               <a:t>Problem Statement</a:t>
             </a:r>
           </a:p>
@@ -3298,27 +3403,53 @@
         <p:txBody>
           <a:bodyPr/>
           <a:lstStyle/>
-          <a:p>
-            <a:r>
-              <a:t>Online job portals are flooded with fraudulent listings.</a:t>
-            </a:r>
-          </a:p>
+          <a:p/>
           <a:p>
             <a:pPr/>
             <a:r>
+              <a:rPr sz="2200">
+                <a:solidFill>
+                  <a:srgbClr val="F0F0F0"/>
+                </a:solidFill>
+                <a:latin typeface="Segoe UI"/>
+              </a:rPr>
+              <a:t>Online job portals are increasingly flooded with fraudulent listings.</a:t>
+            </a:r>
+          </a:p>
+          <a:p>
+            <a:pPr/>
+            <a:r>
+              <a:rPr sz="2200">
+                <a:solidFill>
+                  <a:srgbClr val="F0F0F0"/>
+                </a:solidFill>
+                <a:latin typeface="Segoe UI"/>
+              </a:rPr>
               <a:t>Scams target vulnerable job seekers to extract money or personal info.</a:t>
             </a:r>
           </a:p>
           <a:p>
             <a:pPr/>
             <a:r>
+              <a:rPr sz="2200">
+                <a:solidFill>
+                  <a:srgbClr val="F0F0F0"/>
+                </a:solidFill>
+                <a:latin typeface="Segoe UI"/>
+              </a:rPr>
               <a:t>Traditional spam filters fail because scams use professional, legitimate-sounding language.</a:t>
             </a:r>
           </a:p>
           <a:p>
             <a:pPr/>
             <a:r>
-              <a:t>There is a need for a real-time, automated detection tool.</a:t>
+              <a:rPr sz="2200">
+                <a:solidFill>
+                  <a:srgbClr val="F0F0F0"/>
+                </a:solidFill>
+                <a:latin typeface="Segoe UI"/>
+              </a:rPr>
+              <a:t>There is an urgent need for an automated, NLP-based detection tool.</a:t>
             </a:r>
           </a:p>
         </p:txBody>
@@ -3334,6 +3465,14 @@
 <file path=ppt/slides/slide3.xml><?xml version="1.0" encoding="utf-8"?>
 <p:sld xmlns:a="http://schemas.openxmlformats.org/drawingml/2006/main" xmlns:p="http://schemas.openxmlformats.org/presentationml/2006/main" xmlns:r="http://schemas.openxmlformats.org/officeDocument/2006/relationships">
   <p:cSld>
+    <p:bg>
+      <p:bgPr>
+        <a:solidFill>
+          <a:srgbClr val="18212D"/>
+        </a:solidFill>
+        <a:effectLst/>
+      </p:bgPr>
+    </p:bg>
     <p:spTree>
       <p:nvGrpSpPr>
         <p:cNvPr id="1" name=""/>
@@ -3357,6 +3496,12 @@
           <a:lstStyle/>
           <a:p>
             <a:r>
+              <a:rPr sz="4000" b="1">
+                <a:solidFill>
+                  <a:srgbClr val="40E0D0"/>
+                </a:solidFill>
+                <a:latin typeface="Segoe UI"/>
+              </a:rPr>
               <a:t>Project Objectives</a:t>
             </a:r>
           </a:p>
@@ -3376,32 +3521,64 @@
         <p:txBody>
           <a:bodyPr/>
           <a:lstStyle/>
-          <a:p>
-            <a:r>
+          <a:p/>
+          <a:p>
+            <a:pPr/>
+            <a:r>
+              <a:rPr sz="2200">
+                <a:solidFill>
+                  <a:srgbClr val="F0F0F0"/>
+                </a:solidFill>
+                <a:latin typeface="Segoe UI"/>
+              </a:rPr>
               <a:t>Preprocess and extract features from unstructured job posting text.</a:t>
             </a:r>
           </a:p>
           <a:p>
             <a:pPr/>
             <a:r>
+              <a:rPr sz="2200">
+                <a:solidFill>
+                  <a:srgbClr val="F0F0F0"/>
+                </a:solidFill>
+                <a:latin typeface="Segoe UI"/>
+              </a:rPr>
               <a:t>Train and compare multiple Machine Learning algorithms.</a:t>
             </a:r>
           </a:p>
           <a:p>
             <a:pPr/>
             <a:r>
-              <a:t>Address severe class imbalance mathematically.</a:t>
+              <a:rPr sz="2200">
+                <a:solidFill>
+                  <a:srgbClr val="F0F0F0"/>
+                </a:solidFill>
+                <a:latin typeface="Segoe UI"/>
+              </a:rPr>
+              <a:t>Address severe class imbalance using mathematical weighting.</a:t>
             </a:r>
           </a:p>
           <a:p>
             <a:pPr/>
             <a:r>
+              <a:rPr sz="2200">
+                <a:solidFill>
+                  <a:srgbClr val="F0F0F0"/>
+                </a:solidFill>
+                <a:latin typeface="Segoe UI"/>
+              </a:rPr>
               <a:t>Develop an automated pipeline for intelligent model selection.</a:t>
             </a:r>
           </a:p>
           <a:p>
             <a:pPr/>
             <a:r>
+              <a:rPr sz="2200">
+                <a:solidFill>
+                  <a:srgbClr val="F0F0F0"/>
+                </a:solidFill>
+                <a:latin typeface="Segoe UI"/>
+              </a:rPr>
               <a:t>Build an interactive web dashboard for real-time predictions.</a:t>
             </a:r>
           </a:p>
@@ -3418,6 +3595,14 @@
 <file path=ppt/slides/slide4.xml><?xml version="1.0" encoding="utf-8"?>
 <p:sld xmlns:a="http://schemas.openxmlformats.org/drawingml/2006/main" xmlns:p="http://schemas.openxmlformats.org/presentationml/2006/main" xmlns:r="http://schemas.openxmlformats.org/officeDocument/2006/relationships">
   <p:cSld>
+    <p:bg>
+      <p:bgPr>
+        <a:solidFill>
+          <a:srgbClr val="18212D"/>
+        </a:solidFill>
+        <a:effectLst/>
+      </p:bgPr>
+    </p:bg>
     <p:spTree>
       <p:nvGrpSpPr>
         <p:cNvPr id="1" name=""/>
@@ -3441,6 +3626,12 @@
           <a:lstStyle/>
           <a:p>
             <a:r>
+              <a:rPr sz="4000" b="1">
+                <a:solidFill>
+                  <a:srgbClr val="40E0D0"/>
+                </a:solidFill>
+                <a:latin typeface="Segoe UI"/>
+              </a:rPr>
               <a:t>Dataset: EMSCAD</a:t>
             </a:r>
           </a:p>
@@ -3460,33 +3651,65 @@
         <p:txBody>
           <a:bodyPr/>
           <a:lstStyle/>
-          <a:p>
-            <a:r>
-              <a:t>Employment Scam Aegean Dataset (from Kaggle).</a:t>
-            </a:r>
-          </a:p>
+          <a:p/>
           <a:p>
             <a:pPr/>
             <a:r>
+              <a:rPr sz="2200">
+                <a:solidFill>
+                  <a:srgbClr val="F0F0F0"/>
+                </a:solidFill>
+                <a:latin typeface="Segoe UI"/>
+              </a:rPr>
+              <a:t>Employment Scam Aegean Dataset (sourced from Kaggle).</a:t>
+            </a:r>
+          </a:p>
+          <a:p>
+            <a:pPr/>
+            <a:r>
+              <a:rPr sz="2200">
+                <a:solidFill>
+                  <a:srgbClr val="F0F0F0"/>
+                </a:solidFill>
+                <a:latin typeface="Segoe UI"/>
+              </a:rPr>
               <a:t>Total Records: ~17,880 job postings.</a:t>
             </a:r>
           </a:p>
           <a:p>
             <a:pPr/>
             <a:r>
+              <a:rPr sz="2200">
+                <a:solidFill>
+                  <a:srgbClr val="F0F0F0"/>
+                </a:solidFill>
+                <a:latin typeface="Segoe UI"/>
+              </a:rPr>
               <a:t>Features used: Title, Company Profile, Description, Requirements, Benefits.</a:t>
             </a:r>
           </a:p>
           <a:p>
             <a:pPr/>
             <a:r>
+              <a:rPr sz="2200">
+                <a:solidFill>
+                  <a:srgbClr val="F0F0F0"/>
+                </a:solidFill>
+                <a:latin typeface="Segoe UI"/>
+              </a:rPr>
               <a:t>Target Variable: 'fraudulent' (0 = Real, 1 = Fake).</a:t>
             </a:r>
           </a:p>
           <a:p>
             <a:pPr/>
             <a:r>
-              <a:t>Challenge: Severe Imbalance. Only ~5% of jobs are fraudulent.</a:t>
+              <a:rPr sz="2200">
+                <a:solidFill>
+                  <a:srgbClr val="F0F0F0"/>
+                </a:solidFill>
+                <a:latin typeface="Segoe UI"/>
+              </a:rPr>
+              <a:t>Challenge: Severe Imbalance. Only ~5% of jobs in the dataset are fraudulent.</a:t>
             </a:r>
           </a:p>
         </p:txBody>
@@ -3502,6 +3725,14 @@
 <file path=ppt/slides/slide5.xml><?xml version="1.0" encoding="utf-8"?>
 <p:sld xmlns:a="http://schemas.openxmlformats.org/drawingml/2006/main" xmlns:p="http://schemas.openxmlformats.org/presentationml/2006/main" xmlns:r="http://schemas.openxmlformats.org/officeDocument/2006/relationships">
   <p:cSld>
+    <p:bg>
+      <p:bgPr>
+        <a:solidFill>
+          <a:srgbClr val="18212D"/>
+        </a:solidFill>
+        <a:effectLst/>
+      </p:bgPr>
+    </p:bg>
     <p:spTree>
       <p:nvGrpSpPr>
         <p:cNvPr id="1" name=""/>
@@ -3525,6 +3756,12 @@
           <a:lstStyle/>
           <a:p>
             <a:r>
+              <a:rPr sz="4000" b="1">
+                <a:solidFill>
+                  <a:srgbClr val="40E0D0"/>
+                </a:solidFill>
+                <a:latin typeface="Segoe UI"/>
+              </a:rPr>
               <a:t>Data Preprocessing &amp; NLP</a:t>
             </a:r>
           </a:p>
@@ -3544,33 +3781,65 @@
         <p:txBody>
           <a:bodyPr/>
           <a:lstStyle/>
-          <a:p>
-            <a:r>
-              <a:t>Missing Data: Filled empty text fields instead of dropping rows.</a:t>
-            </a:r>
-          </a:p>
+          <a:p/>
           <a:p>
             <a:pPr/>
             <a:r>
+              <a:rPr sz="2200">
+                <a:solidFill>
+                  <a:srgbClr val="F0F0F0"/>
+                </a:solidFill>
+                <a:latin typeface="Segoe UI"/>
+              </a:rPr>
+              <a:t>Missing Data: Filled empty text fields instead of dropping rows to preserve data.</a:t>
+            </a:r>
+          </a:p>
+          <a:p>
+            <a:pPr/>
+            <a:r>
+              <a:rPr sz="2200">
+                <a:solidFill>
+                  <a:srgbClr val="F0F0F0"/>
+                </a:solidFill>
+                <a:latin typeface="Segoe UI"/>
+              </a:rPr>
               <a:t>Feature Engineering: Concatenated all text features into a single 'full_text' column.</a:t>
             </a:r>
           </a:p>
           <a:p>
             <a:pPr/>
             <a:r>
+              <a:rPr sz="2200">
+                <a:solidFill>
+                  <a:srgbClr val="F0F0F0"/>
+                </a:solidFill>
+                <a:latin typeface="Segoe UI"/>
+              </a:rPr>
               <a:t>NLP Cleaning: Converted to lowercase, removed punctuation and numbers.</a:t>
             </a:r>
           </a:p>
           <a:p>
             <a:pPr/>
             <a:r>
+              <a:rPr sz="2200">
+                <a:solidFill>
+                  <a:srgbClr val="F0F0F0"/>
+                </a:solidFill>
+                <a:latin typeface="Segoe UI"/>
+              </a:rPr>
               <a:t>Vectorization: Used TF-IDF (Term Frequency-Inverse Document Frequency).</a:t>
             </a:r>
           </a:p>
           <a:p>
             <a:pPr/>
             <a:r>
-              <a:t>N-grams: Used unigrams and bigrams (e.g., 'wire transfer') to capture context.</a:t>
+              <a:rPr sz="2200">
+                <a:solidFill>
+                  <a:srgbClr val="F0F0F0"/>
+                </a:solidFill>
+                <a:latin typeface="Segoe UI"/>
+              </a:rPr>
+              <a:t>N-grams: Extracted both unigrams and bigrams (e.g., 'wire transfer') for context.</a:t>
             </a:r>
           </a:p>
         </p:txBody>
@@ -3586,6 +3855,14 @@
 <file path=ppt/slides/slide6.xml><?xml version="1.0" encoding="utf-8"?>
 <p:sld xmlns:a="http://schemas.openxmlformats.org/drawingml/2006/main" xmlns:p="http://schemas.openxmlformats.org/presentationml/2006/main" xmlns:r="http://schemas.openxmlformats.org/officeDocument/2006/relationships">
   <p:cSld>
+    <p:bg>
+      <p:bgPr>
+        <a:solidFill>
+          <a:srgbClr val="18212D"/>
+        </a:solidFill>
+        <a:effectLst/>
+      </p:bgPr>
+    </p:bg>
     <p:spTree>
       <p:nvGrpSpPr>
         <p:cNvPr id="1" name=""/>
@@ -3609,6 +3886,12 @@
           <a:lstStyle/>
           <a:p>
             <a:r>
+              <a:rPr sz="4000" b="1">
+                <a:solidFill>
+                  <a:srgbClr val="40E0D0"/>
+                </a:solidFill>
+                <a:latin typeface="Segoe UI"/>
+              </a:rPr>
               <a:t>Algorithms Evaluated</a:t>
             </a:r>
           </a:p>
@@ -3628,33 +3911,65 @@
         <p:txBody>
           <a:bodyPr/>
           <a:lstStyle/>
-          <a:p>
-            <a:r>
-              <a:t>1. Logistic Regression: Fast, interpretable baseline.</a:t>
-            </a:r>
-          </a:p>
+          <a:p/>
           <a:p>
             <a:pPr/>
             <a:r>
-              <a:t>2. Naive Bayes: Classic NLP text classifier.</a:t>
+              <a:rPr sz="2200">
+                <a:solidFill>
+                  <a:srgbClr val="F0F0F0"/>
+                </a:solidFill>
+                <a:latin typeface="Segoe UI"/>
+              </a:rPr>
+              <a:t>1. Logistic Regression: A fast, interpretable baseline.</a:t>
             </a:r>
           </a:p>
           <a:p>
             <a:pPr/>
             <a:r>
-              <a:t>3. Random Forest: Ensemble method to capture non-linear patterns.</a:t>
+              <a:rPr sz="2200">
+                <a:solidFill>
+                  <a:srgbClr val="F0F0F0"/>
+                </a:solidFill>
+                <a:latin typeface="Segoe UI"/>
+              </a:rPr>
+              <a:t>2. Naive Bayes: The classic NLP text classifier.</a:t>
             </a:r>
           </a:p>
           <a:p>
             <a:pPr/>
             <a:r>
-              <a:t>4. Linear SVC: Support Vector Machine optimized for high-dimensional, sparse TF-IDF matrices.</a:t>
+              <a:rPr sz="2200">
+                <a:solidFill>
+                  <a:srgbClr val="F0F0F0"/>
+                </a:solidFill>
+                <a:latin typeface="Segoe UI"/>
+              </a:rPr>
+              <a:t>3. Random Forest: An ensemble method to capture non-linear patterns.</a:t>
             </a:r>
           </a:p>
           <a:p>
             <a:pPr/>
             <a:r>
-              <a:t>Crucial Step: Used 'class_weight=balanced' to force algorithms to penalize errors on minority class.</a:t>
+              <a:rPr sz="2200">
+                <a:solidFill>
+                  <a:srgbClr val="F0F0F0"/>
+                </a:solidFill>
+                <a:latin typeface="Segoe UI"/>
+              </a:rPr>
+              <a:t>4. Linear SVC: A Support Vector Machine optimized for sparse TF-IDF matrices.</a:t>
+            </a:r>
+          </a:p>
+          <a:p>
+            <a:pPr/>
+            <a:r>
+              <a:rPr sz="2200">
+                <a:solidFill>
+                  <a:srgbClr val="F0F0F0"/>
+                </a:solidFill>
+                <a:latin typeface="Segoe UI"/>
+              </a:rPr>
+              <a:t>Crucial Step: Used 'class_weight=balanced' to force algorithms to penalize errors heavily on the minority class.</a:t>
             </a:r>
           </a:p>
         </p:txBody>
@@ -3670,6 +3985,14 @@
 <file path=ppt/slides/slide7.xml><?xml version="1.0" encoding="utf-8"?>
 <p:sld xmlns:a="http://schemas.openxmlformats.org/drawingml/2006/main" xmlns:p="http://schemas.openxmlformats.org/presentationml/2006/main" xmlns:r="http://schemas.openxmlformats.org/officeDocument/2006/relationships">
   <p:cSld>
+    <p:bg>
+      <p:bgPr>
+        <a:solidFill>
+          <a:srgbClr val="18212D"/>
+        </a:solidFill>
+        <a:effectLst/>
+      </p:bgPr>
+    </p:bg>
     <p:spTree>
       <p:nvGrpSpPr>
         <p:cNvPr id="1" name=""/>
@@ -3693,6 +4016,12 @@
           <a:lstStyle/>
           <a:p>
             <a:r>
+              <a:rPr sz="4000" b="1">
+                <a:solidFill>
+                  <a:srgbClr val="40E0D0"/>
+                </a:solidFill>
+                <a:latin typeface="Segoe UI"/>
+              </a:rPr>
               <a:t>Why Accuracy is Misleading</a:t>
             </a:r>
           </a:p>
@@ -3712,32 +4041,64 @@
         <p:txBody>
           <a:bodyPr/>
           <a:lstStyle/>
-          <a:p>
-            <a:r>
+          <a:p/>
+          <a:p>
+            <a:pPr/>
+            <a:r>
+              <a:rPr sz="2200">
+                <a:solidFill>
+                  <a:srgbClr val="F0F0F0"/>
+                </a:solidFill>
+                <a:latin typeface="Segoe UI"/>
+              </a:rPr>
               <a:t>Because 95% of the data is Real, a 'dumb' model predicting 'Real' every time achieves 95% Accuracy.</a:t>
             </a:r>
           </a:p>
           <a:p>
             <a:pPr/>
             <a:r>
+              <a:rPr sz="2200">
+                <a:solidFill>
+                  <a:srgbClr val="F0F0F0"/>
+                </a:solidFill>
+                <a:latin typeface="Segoe UI"/>
+              </a:rPr>
               <a:t>Therefore, we prioritized different metrics:</a:t>
             </a:r>
           </a:p>
           <a:p>
             <a:pPr/>
             <a:r>
+              <a:rPr sz="2200">
+                <a:solidFill>
+                  <a:srgbClr val="F0F0F0"/>
+                </a:solidFill>
+                <a:latin typeface="Segoe UI"/>
+              </a:rPr>
               <a:t>Recall: Out of all actual scams, how many did we catch?</a:t>
             </a:r>
           </a:p>
           <a:p>
             <a:pPr/>
             <a:r>
+              <a:rPr sz="2200">
+                <a:solidFill>
+                  <a:srgbClr val="F0F0F0"/>
+                </a:solidFill>
+                <a:latin typeface="Segoe UI"/>
+              </a:rPr>
               <a:t>Precision: Out of all flagged jobs, how many were actually scams?</a:t>
             </a:r>
           </a:p>
           <a:p>
             <a:pPr/>
             <a:r>
+              <a:rPr sz="2200">
+                <a:solidFill>
+                  <a:srgbClr val="F0F0F0"/>
+                </a:solidFill>
+                <a:latin typeface="Segoe UI"/>
+              </a:rPr>
               <a:t>F1-Score: The harmonic mean of Precision and Recall. This was our primary metric for model selection.</a:t>
             </a:r>
           </a:p>
@@ -3754,6 +4115,14 @@
 <file path=ppt/slides/slide8.xml><?xml version="1.0" encoding="utf-8"?>
 <p:sld xmlns:a="http://schemas.openxmlformats.org/drawingml/2006/main" xmlns:p="http://schemas.openxmlformats.org/presentationml/2006/main" xmlns:r="http://schemas.openxmlformats.org/officeDocument/2006/relationships">
   <p:cSld>
+    <p:bg>
+      <p:bgPr>
+        <a:solidFill>
+          <a:srgbClr val="18212D"/>
+        </a:solidFill>
+        <a:effectLst/>
+      </p:bgPr>
+    </p:bg>
     <p:spTree>
       <p:nvGrpSpPr>
         <p:cNvPr id="1" name=""/>
@@ -3777,6 +4146,12 @@
           <a:lstStyle/>
           <a:p>
             <a:r>
+              <a:rPr sz="4000" b="1">
+                <a:solidFill>
+                  <a:srgbClr val="40E0D0"/>
+                </a:solidFill>
+                <a:latin typeface="Segoe UI"/>
+              </a:rPr>
               <a:t>Model Performance &amp; Selection</a:t>
             </a:r>
           </a:p>
@@ -3796,32 +4171,64 @@
         <p:txBody>
           <a:bodyPr/>
           <a:lstStyle/>
-          <a:p>
-            <a:r>
+          <a:p/>
+          <a:p>
+            <a:pPr/>
+            <a:r>
+              <a:rPr sz="2200">
+                <a:solidFill>
+                  <a:srgbClr val="F0F0F0"/>
+                </a:solidFill>
+                <a:latin typeface="Segoe UI"/>
+              </a:rPr>
               <a:t>Logistic Regression: Accuracy 96.7% | F1-Score 72.8%</a:t>
             </a:r>
           </a:p>
           <a:p>
             <a:pPr/>
             <a:r>
+              <a:rPr sz="2200">
+                <a:solidFill>
+                  <a:srgbClr val="F0F0F0"/>
+                </a:solidFill>
+                <a:latin typeface="Segoe UI"/>
+              </a:rPr>
               <a:t>Naive Bayes: Accuracy 97.0% | F1-Score 58.4%</a:t>
             </a:r>
           </a:p>
           <a:p>
             <a:pPr/>
             <a:r>
+              <a:rPr sz="2200">
+                <a:solidFill>
+                  <a:srgbClr val="F0F0F0"/>
+                </a:solidFill>
+                <a:latin typeface="Segoe UI"/>
+              </a:rPr>
               <a:t>Random Forest: Accuracy 98.1% | F1-Score 77.8%</a:t>
             </a:r>
           </a:p>
           <a:p>
             <a:pPr/>
             <a:r>
+              <a:rPr sz="2200">
+                <a:solidFill>
+                  <a:srgbClr val="F0F0F0"/>
+                </a:solidFill>
+                <a:latin typeface="Segoe UI"/>
+              </a:rPr>
               <a:t>Linear SVC: Accuracy 98.1% | F1-Score 81.5% | Recall 82.6%</a:t>
             </a:r>
           </a:p>
           <a:p>
             <a:pPr/>
             <a:r>
+              <a:rPr sz="2200">
+                <a:solidFill>
+                  <a:srgbClr val="F0F0F0"/>
+                </a:solidFill>
+                <a:latin typeface="Segoe UI"/>
+              </a:rPr>
               <a:t>Winner: Linear SVC. Automatically selected by the pipeline for achieving the highest F1-Score.</a:t>
             </a:r>
           </a:p>
@@ -3838,6 +4245,14 @@
 <file path=ppt/slides/slide9.xml><?xml version="1.0" encoding="utf-8"?>
 <p:sld xmlns:a="http://schemas.openxmlformats.org/drawingml/2006/main" xmlns:p="http://schemas.openxmlformats.org/presentationml/2006/main" xmlns:r="http://schemas.openxmlformats.org/officeDocument/2006/relationships">
   <p:cSld>
+    <p:bg>
+      <p:bgPr>
+        <a:solidFill>
+          <a:srgbClr val="18212D"/>
+        </a:solidFill>
+        <a:effectLst/>
+      </p:bgPr>
+    </p:bg>
     <p:spTree>
       <p:nvGrpSpPr>
         <p:cNvPr id="1" name=""/>
@@ -3861,6 +4276,12 @@
           <a:lstStyle/>
           <a:p>
             <a:r>
+              <a:rPr sz="4000" b="1">
+                <a:solidFill>
+                  <a:srgbClr val="40E0D0"/>
+                </a:solidFill>
+                <a:latin typeface="Segoe UI"/>
+              </a:rPr>
               <a:t>Interactive Dashboard</a:t>
             </a:r>
           </a:p>
@@ -3880,26 +4301,52 @@
         <p:txBody>
           <a:bodyPr/>
           <a:lstStyle/>
-          <a:p>
-            <a:r>
+          <a:p/>
+          <a:p>
+            <a:pPr/>
+            <a:r>
+              <a:rPr sz="2200">
+                <a:solidFill>
+                  <a:srgbClr val="F0F0F0"/>
+                </a:solidFill>
+                <a:latin typeface="Segoe UI"/>
+              </a:rPr>
               <a:t>Built using Python Dash and Dash Bootstrap Components.</a:t>
             </a:r>
           </a:p>
           <a:p>
             <a:pPr/>
             <a:r>
+              <a:rPr sz="2200">
+                <a:solidFill>
+                  <a:srgbClr val="F0F0F0"/>
+                </a:solidFill>
+                <a:latin typeface="Segoe UI"/>
+              </a:rPr>
               <a:t>Features a 'Cyborg' dark-mode premium UI.</a:t>
             </a:r>
           </a:p>
           <a:p>
             <a:pPr/>
             <a:r>
+              <a:rPr sz="2200">
+                <a:solidFill>
+                  <a:srgbClr val="F0F0F0"/>
+                </a:solidFill>
+                <a:latin typeface="Segoe UI"/>
+              </a:rPr>
               <a:t>Real-time Inference: Users paste a job description, and the backend vectorizes and predicts instantly.</a:t>
             </a:r>
           </a:p>
           <a:p>
             <a:pPr/>
             <a:r>
+              <a:rPr sz="2200">
+                <a:solidFill>
+                  <a:srgbClr val="F0F0F0"/>
+                </a:solidFill>
+                <a:latin typeface="Segoe UI"/>
+              </a:rPr>
               <a:t>Model Insights: Visualizes exactly which words the model flagged as 'Fraudulent' based on SVC coefficients.</a:t>
             </a:r>
           </a:p>

</xml_diff>